<commit_message>
Deck: clickable links on slides 1, 2, 5, 7, 8 (also in PDF); PDF download
Co-Authored-By: Claude Opus 5.5 <noreply@anthropic.com>
</commit_message>
<xml_diff>
--- a/EL-01_TeamPreflight.pptx
+++ b/EL-01_TeamPreflight.pptx
@@ -5064,7 +5064,9 @@
       </p:sp>
       <p:pic>
         <p:nvPicPr>
-          <p:cNvPr id="26" name="Picture 25" descr="qr_demo.png"/>
+          <p:cNvPr id="26" name="Picture 25" descr="qr_demo.png">
+            <a:hlinkClick r:id="rId9"/>
+          </p:cNvPr>
           <p:cNvPicPr>
             <a:picLocks noChangeAspect="1"/>
           </p:cNvPicPr>
@@ -5088,14 +5090,16 @@
       </p:pic>
       <p:sp>
         <p:nvSpPr>
-          <p:cNvPr id="27" name="TextBox 26"/>
+          <p:cNvPr id="27" name="TextBox 26">
+            <a:hlinkClick r:id="rId9"/>
+          </p:cNvPr>
           <p:cNvSpPr txBox="1"/>
           <p:nvPr/>
         </p:nvSpPr>
         <p:spPr>
           <a:xfrm>
-            <a:off x="14676120" y="7882127"/>
-            <a:ext cx="1737360" cy="365760"/>
+            <a:off x="14401800" y="7882127"/>
+            <a:ext cx="2286000" cy="365760"/>
           </a:xfrm>
           <a:prstGeom prst="rect">
             <a:avLst/>
@@ -5117,13 +5121,20 @@
               </a:spcAft>
             </a:pPr>
             <a:r>
-              <a:rPr sz="1540" b="0">
+              <a:rPr sz="1540" b="0" u="sng">
                 <a:solidFill>
                   <a:srgbClr val="003470"/>
                 </a:solidFill>
                 <a:latin typeface="Agrandir Bold"/>
-              </a:rPr>
-              <a:t>Scan: live demo</a:t>
+                <a:hlinkClick r:id="rId9">
+                  <a:extLst>
+                    <a:ext uri="{A12FA001-AC4F-418D-AE19-62706E023703}">
+                      <ahyp:hlinkClr xmlns:ahyp="http://schemas.microsoft.com/office/drawing/2018/hyperlinkcolor" val="tx"/>
+                    </a:ext>
+                  </a:extLst>
+                </a:hlinkClick>
+              </a:rPr>
+              <a:t>Open the live demo</a:t>
             </a:r>
           </a:p>
         </p:txBody>
@@ -7193,7 +7204,9 @@
       </p:sp>
       <p:pic>
         <p:nvPicPr>
-          <p:cNvPr id="42" name="Picture 41" descr="claims.png"/>
+          <p:cNvPr id="42" name="Picture 41" descr="claims.png">
+            <a:hlinkClick r:id="rId4"/>
+          </p:cNvPr>
           <p:cNvPicPr>
             <a:picLocks noChangeAspect="1"/>
           </p:cNvPicPr>
@@ -7253,6 +7266,57 @@
                 <a:latin typeface="Agrandir"/>
               </a:rPr>
               <a:t>Claim Ledger for Paper A: every number, its verdict and its cause</a:t>
+            </a:r>
+          </a:p>
+        </p:txBody>
+      </p:sp>
+      <p:sp>
+        <p:nvSpPr>
+          <p:cNvPr id="44" name="TextBox 43">
+            <a:hlinkClick r:id="rId4"/>
+          </p:cNvPr>
+          <p:cNvSpPr txBox="1"/>
+          <p:nvPr/>
+        </p:nvSpPr>
+        <p:spPr>
+          <a:xfrm>
+            <a:off x="11475720" y="8362038"/>
+            <a:ext cx="6172200" cy="365760"/>
+          </a:xfrm>
+          <a:prstGeom prst="rect">
+            <a:avLst/>
+          </a:prstGeom>
+          <a:noFill/>
+        </p:spPr>
+        <p:txBody>
+          <a:bodyPr wrap="square" lIns="0" rIns="0" tIns="0" bIns="0" anchor="t">
+            <a:spAutoFit/>
+          </a:bodyPr>
+          <a:lstStyle/>
+          <a:p>
+            <a:pPr algn="l">
+              <a:lnSpc>
+                <a:spcPct val="105000"/>
+              </a:lnSpc>
+              <a:spcAft>
+                <a:spcPts val="400"/>
+              </a:spcAft>
+            </a:pPr>
+            <a:r>
+              <a:rPr sz="1680" b="0" u="sng">
+                <a:solidFill>
+                  <a:srgbClr val="FF914D"/>
+                </a:solidFill>
+                <a:latin typeface="Agrandir Bold"/>
+                <a:hlinkClick r:id="rId4">
+                  <a:extLst>
+                    <a:ext uri="{A12FA001-AC4F-418D-AE19-62706E023703}">
+                      <ahyp:hlinkClr xmlns:ahyp="http://schemas.microsoft.com/office/drawing/2018/hyperlinkcolor" val="tx"/>
+                    </a:ext>
+                  </a:extLst>
+                </a:hlinkClick>
+              </a:rPr>
+              <a:t>Open this ledger live →</a:t>
             </a:r>
           </a:p>
         </p:txBody>
@@ -14461,7 +14525,58 @@
       </p:sp>
       <p:sp>
         <p:nvSpPr>
-          <p:cNvPr id="19" name="TextBox 18"/>
+          <p:cNvPr id="19" name="TextBox 18">
+            <a:hlinkClick r:id="rId3"/>
+          </p:cNvPr>
+          <p:cNvSpPr txBox="1"/>
+          <p:nvPr/>
+        </p:nvSpPr>
+        <p:spPr>
+          <a:xfrm>
+            <a:off x="4480560" y="2542032"/>
+            <a:ext cx="4352544" cy="365760"/>
+          </a:xfrm>
+          <a:prstGeom prst="rect">
+            <a:avLst/>
+          </a:prstGeom>
+          <a:noFill/>
+        </p:spPr>
+        <p:txBody>
+          <a:bodyPr wrap="square" lIns="0" rIns="0" tIns="0" bIns="0" anchor="t">
+            <a:spAutoFit/>
+          </a:bodyPr>
+          <a:lstStyle/>
+          <a:p>
+            <a:pPr algn="r">
+              <a:lnSpc>
+                <a:spcPct val="105000"/>
+              </a:lnSpc>
+              <a:spcAft>
+                <a:spcPts val="400"/>
+              </a:spcAft>
+            </a:pPr>
+            <a:r>
+              <a:rPr sz="1610" b="0" u="sng">
+                <a:solidFill>
+                  <a:srgbClr val="FF914D"/>
+                </a:solidFill>
+                <a:latin typeface="Agrandir Bold"/>
+                <a:hlinkClick r:id="rId3">
+                  <a:extLst>
+                    <a:ext uri="{A12FA001-AC4F-418D-AE19-62706E023703}">
+                      <ahyp:hlinkClr xmlns:ahyp="http://schemas.microsoft.com/office/drawing/2018/hyperlinkcolor" val="tx"/>
+                    </a:ext>
+                  </a:extLst>
+                </a:hlinkClick>
+              </a:rPr>
+              <a:t>Run Paper A live →</a:t>
+            </a:r>
+          </a:p>
+        </p:txBody>
+      </p:sp>
+      <p:sp>
+        <p:nvSpPr>
+          <p:cNvPr id="20" name="TextBox 19"/>
           <p:cNvSpPr txBox="1"/>
           <p:nvPr/>
         </p:nvSpPr>
@@ -14503,7 +14618,7 @@
       </p:sp>
       <p:graphicFrame>
         <p:nvGraphicFramePr>
-          <p:cNvPr id="20" name="Table 19"/>
+          <p:cNvPr id="21" name="Table 20"/>
           <p:cNvGraphicFramePr>
             <a:graphicFrameLocks noGrp="1"/>
           </p:cNvGraphicFramePr>
@@ -14851,7 +14966,7 @@
       </p:graphicFrame>
       <p:sp>
         <p:nvSpPr>
-          <p:cNvPr id="21" name="TextBox 20"/>
+          <p:cNvPr id="22" name="TextBox 21"/>
           <p:cNvSpPr txBox="1"/>
           <p:nvPr/>
         </p:nvSpPr>
@@ -14893,7 +15008,7 @@
       </p:sp>
       <p:sp>
         <p:nvSpPr>
-          <p:cNvPr id="22" name="Rounded Rectangle 21"/>
+          <p:cNvPr id="23" name="Rounded Rectangle 22"/>
           <p:cNvSpPr/>
           <p:nvPr/>
         </p:nvSpPr>
@@ -14939,7 +15054,7 @@
       </p:sp>
       <p:sp>
         <p:nvSpPr>
-          <p:cNvPr id="23" name="TextBox 22"/>
+          <p:cNvPr id="24" name="TextBox 23"/>
           <p:cNvSpPr txBox="1"/>
           <p:nvPr/>
         </p:nvSpPr>
@@ -14981,7 +15096,7 @@
       </p:sp>
       <p:sp>
         <p:nvSpPr>
-          <p:cNvPr id="24" name="TextBox 23"/>
+          <p:cNvPr id="25" name="TextBox 24"/>
           <p:cNvSpPr txBox="1"/>
           <p:nvPr/>
         </p:nvSpPr>
@@ -15023,7 +15138,7 @@
       </p:sp>
       <p:sp>
         <p:nvSpPr>
-          <p:cNvPr id="25" name="Rounded Rectangle 24"/>
+          <p:cNvPr id="26" name="Rounded Rectangle 25"/>
           <p:cNvSpPr/>
           <p:nvPr/>
         </p:nvSpPr>
@@ -15069,7 +15184,7 @@
       </p:sp>
       <p:sp>
         <p:nvSpPr>
-          <p:cNvPr id="26" name="TextBox 25"/>
+          <p:cNvPr id="27" name="TextBox 26"/>
           <p:cNvSpPr txBox="1"/>
           <p:nvPr/>
         </p:nvSpPr>
@@ -15111,7 +15226,7 @@
       </p:sp>
       <p:sp>
         <p:nvSpPr>
-          <p:cNvPr id="27" name="TextBox 26"/>
+          <p:cNvPr id="28" name="TextBox 27"/>
           <p:cNvSpPr txBox="1"/>
           <p:nvPr/>
         </p:nvSpPr>
@@ -15153,7 +15268,7 @@
       </p:sp>
       <p:sp>
         <p:nvSpPr>
-          <p:cNvPr id="28" name="Rounded Rectangle 27"/>
+          <p:cNvPr id="29" name="Rounded Rectangle 28"/>
           <p:cNvSpPr/>
           <p:nvPr/>
         </p:nvSpPr>
@@ -15199,7 +15314,7 @@
       </p:sp>
       <p:sp>
         <p:nvSpPr>
-          <p:cNvPr id="29" name="TextBox 28"/>
+          <p:cNvPr id="30" name="TextBox 29"/>
           <p:cNvSpPr txBox="1"/>
           <p:nvPr/>
         </p:nvSpPr>
@@ -15241,7 +15356,7 @@
       </p:sp>
       <p:sp>
         <p:nvSpPr>
-          <p:cNvPr id="30" name="TextBox 29"/>
+          <p:cNvPr id="31" name="TextBox 30"/>
           <p:cNvSpPr txBox="1"/>
           <p:nvPr/>
         </p:nvSpPr>
@@ -15283,7 +15398,7 @@
       </p:sp>
       <p:sp>
         <p:nvSpPr>
-          <p:cNvPr id="31" name="Rounded Rectangle 30"/>
+          <p:cNvPr id="32" name="Rounded Rectangle 31"/>
           <p:cNvSpPr/>
           <p:nvPr/>
         </p:nvSpPr>
@@ -15327,7 +15442,7 @@
       </p:sp>
       <p:sp>
         <p:nvSpPr>
-          <p:cNvPr id="32" name="TextBox 31"/>
+          <p:cNvPr id="33" name="TextBox 32"/>
           <p:cNvSpPr txBox="1"/>
           <p:nvPr/>
         </p:nvSpPr>
@@ -18668,8 +18783,8 @@
         </p:nvSpPr>
         <p:spPr>
           <a:xfrm>
-            <a:off x="9646920" y="3337560"/>
-            <a:ext cx="2377440" cy="457200"/>
+            <a:off x="9646920" y="3310128"/>
+            <a:ext cx="2011680" cy="457200"/>
           </a:xfrm>
           <a:prstGeom prst="rect">
             <a:avLst/>
@@ -18712,8 +18827,8 @@
         </p:nvSpPr>
         <p:spPr>
           <a:xfrm>
-            <a:off x="11978640" y="3337560"/>
-            <a:ext cx="3840480" cy="731520"/>
+            <a:off x="11658600" y="3346704"/>
+            <a:ext cx="4114800" cy="548640"/>
           </a:xfrm>
           <a:prstGeom prst="rect">
             <a:avLst/>
@@ -18735,13 +18850,20 @@
               </a:spcAft>
             </a:pPr>
             <a:r>
-              <a:rPr sz="1610" b="0">
-                <a:solidFill>
-                  <a:srgbClr val="FFFFFF"/>
+              <a:rPr sz="1610" b="0" u="sng">
+                <a:solidFill>
+                  <a:srgbClr val="FFCD82"/>
                 </a:solidFill>
                 <a:latin typeface="Agrandir"/>
-              </a:rPr>
-              <a:t>preflight-el01.github.io/preflight/</a:t>
+                <a:hlinkClick r:id="rId3">
+                  <a:extLst>
+                    <a:ext uri="{A12FA001-AC4F-418D-AE19-62706E023703}">
+                      <ahyp:hlinkClr xmlns:ahyp="http://schemas.microsoft.com/office/drawing/2018/hyperlinkcolor" val="tx"/>
+                    </a:ext>
+                  </a:extLst>
+                </a:hlinkClick>
+              </a:rPr>
+              <a:t>preflight-el01.github.io/preflight</a:t>
             </a:r>
           </a:p>
         </p:txBody>
@@ -18754,8 +18876,8 @@
         </p:nvSpPr>
         <p:spPr>
           <a:xfrm>
-            <a:off x="9646920" y="4114800"/>
-            <a:ext cx="2377440" cy="457200"/>
+            <a:off x="9646920" y="3931920"/>
+            <a:ext cx="2011680" cy="457200"/>
           </a:xfrm>
           <a:prstGeom prst="rect">
             <a:avLst/>
@@ -18798,8 +18920,8 @@
         </p:nvSpPr>
         <p:spPr>
           <a:xfrm>
-            <a:off x="11978640" y="4114800"/>
-            <a:ext cx="3840480" cy="731520"/>
+            <a:off x="11658600" y="3968496"/>
+            <a:ext cx="4114800" cy="548640"/>
           </a:xfrm>
           <a:prstGeom prst="rect">
             <a:avLst/>
@@ -18821,11 +18943,18 @@
               </a:spcAft>
             </a:pPr>
             <a:r>
-              <a:rPr sz="1610" b="0">
-                <a:solidFill>
-                  <a:srgbClr val="FFFFFF"/>
+              <a:rPr sz="1610" b="0" u="sng">
+                <a:solidFill>
+                  <a:srgbClr val="FFCD82"/>
                 </a:solidFill>
                 <a:latin typeface="Agrandir"/>
+                <a:hlinkClick r:id="rId4">
+                  <a:extLst>
+                    <a:ext uri="{A12FA001-AC4F-418D-AE19-62706E023703}">
+                      <ahyp:hlinkClr xmlns:ahyp="http://schemas.microsoft.com/office/drawing/2018/hyperlinkcolor" val="tx"/>
+                    </a:ext>
+                  </a:extLst>
+                </a:hlinkClick>
               </a:rPr>
               <a:t>github.com/preflight-el01/preflight</a:t>
             </a:r>
@@ -18840,8 +18969,8 @@
         </p:nvSpPr>
         <p:spPr>
           <a:xfrm>
-            <a:off x="9646920" y="4892040"/>
-            <a:ext cx="2377440" cy="457200"/>
+            <a:off x="9646920" y="4553712"/>
+            <a:ext cx="2011680" cy="457200"/>
           </a:xfrm>
           <a:prstGeom prst="rect">
             <a:avLst/>
@@ -18869,7 +18998,7 @@
                 </a:solidFill>
                 <a:latin typeface="Agrandir Bold"/>
               </a:rPr>
-              <a:t>90-second video</a:t>
+              <a:t>Video</a:t>
             </a:r>
           </a:p>
         </p:txBody>
@@ -18884,8 +19013,8 @@
         </p:nvSpPr>
         <p:spPr>
           <a:xfrm>
-            <a:off x="11978640" y="4892040"/>
-            <a:ext cx="3840480" cy="731520"/>
+            <a:off x="11658600" y="4590288"/>
+            <a:ext cx="4114800" cy="548640"/>
           </a:xfrm>
           <a:prstGeom prst="rect">
             <a:avLst/>
@@ -18907,51 +19036,78 @@
               </a:spcAft>
             </a:pPr>
             <a:r>
-              <a:rPr sz="1610" b="0">
-                <a:solidFill>
-                  <a:srgbClr val="FFFFFF"/>
+              <a:rPr sz="1610" b="0" u="sng">
+                <a:solidFill>
+                  <a:srgbClr val="FFCD82"/>
                 </a:solidFill>
                 <a:latin typeface="Agrandir"/>
-              </a:rPr>
-              <a:t>preflight-el01.github.io/preflight/preflight-demo.mp4</a:t>
-            </a:r>
-          </a:p>
-        </p:txBody>
-      </p:sp>
-      <p:pic>
-        <p:nvPicPr>
-          <p:cNvPr id="38" name="Picture 37" descr="qr_demo.png"/>
-          <p:cNvPicPr>
-            <a:picLocks noChangeAspect="1"/>
-          </p:cNvPicPr>
-          <p:nvPr/>
-        </p:nvPicPr>
-        <p:blipFill>
-          <a:blip r:embed="rId6"/>
-          <a:stretch>
-            <a:fillRect/>
-          </a:stretch>
-        </p:blipFill>
-        <p:spPr>
-          <a:xfrm>
-            <a:off x="15910559" y="3246120"/>
-            <a:ext cx="1508760" cy="1508760"/>
+                <a:hlinkClick r:id="rId5">
+                  <a:extLst>
+                    <a:ext uri="{A12FA001-AC4F-418D-AE19-62706E023703}">
+                      <ahyp:hlinkClr xmlns:ahyp="http://schemas.microsoft.com/office/drawing/2018/hyperlinkcolor" val="tx"/>
+                    </a:ext>
+                  </a:extLst>
+                </a:hlinkClick>
+              </a:rPr>
+              <a:t>Watch the 90-second walkthrough</a:t>
+            </a:r>
+          </a:p>
+        </p:txBody>
+      </p:sp>
+      <p:sp>
+        <p:nvSpPr>
+          <p:cNvPr id="38" name="TextBox 37"/>
+          <p:cNvSpPr txBox="1"/>
+          <p:nvPr/>
+        </p:nvSpPr>
+        <p:spPr>
+          <a:xfrm>
+            <a:off x="9646920" y="5175504"/>
+            <a:ext cx="2011680" cy="457200"/>
           </a:xfrm>
           <a:prstGeom prst="rect">
             <a:avLst/>
           </a:prstGeom>
-        </p:spPr>
-      </p:pic>
-      <p:sp>
-        <p:nvSpPr>
-          <p:cNvPr id="39" name="TextBox 38"/>
+          <a:noFill/>
+        </p:spPr>
+        <p:txBody>
+          <a:bodyPr wrap="square" lIns="0" rIns="0" tIns="0" bIns="0" anchor="t">
+            <a:spAutoFit/>
+          </a:bodyPr>
+          <a:lstStyle/>
+          <a:p>
+            <a:pPr algn="l">
+              <a:lnSpc>
+                <a:spcPct val="105000"/>
+              </a:lnSpc>
+              <a:spcAft>
+                <a:spcPts val="400"/>
+              </a:spcAft>
+            </a:pPr>
+            <a:r>
+              <a:rPr sz="1960" b="0">
+                <a:solidFill>
+                  <a:srgbClr val="FFFFFF"/>
+                </a:solidFill>
+                <a:latin typeface="Agrandir Bold"/>
+              </a:rPr>
+              <a:t>Test kit</a:t>
+            </a:r>
+          </a:p>
+        </p:txBody>
+      </p:sp>
+      <p:sp>
+        <p:nvSpPr>
+          <p:cNvPr id="39" name="TextBox 38">
+            <a:hlinkClick r:id="rId6"/>
+          </p:cNvPr>
           <p:cNvSpPr txBox="1"/>
           <p:nvPr/>
         </p:nvSpPr>
         <p:spPr>
           <a:xfrm>
-            <a:off x="9646920" y="6053328"/>
-            <a:ext cx="7772400" cy="822960"/>
+            <a:off x="11658600" y="5212080"/>
+            <a:ext cx="4114800" cy="548640"/>
           </a:xfrm>
           <a:prstGeom prst="rect">
             <a:avLst/>
@@ -18973,20 +19129,120 @@
               </a:spcAft>
             </a:pPr>
             <a:r>
+              <a:rPr sz="1610" b="0" u="sng">
+                <a:solidFill>
+                  <a:srgbClr val="FFCD82"/>
+                </a:solidFill>
+                <a:latin typeface="Agrandir"/>
+                <a:hlinkClick r:id="rId6">
+                  <a:extLst>
+                    <a:ext uri="{A12FA001-AC4F-418D-AE19-62706E023703}">
+                      <ahyp:hlinkClr xmlns:ahyp="http://schemas.microsoft.com/office/drawing/2018/hyperlinkcolor" val="tx"/>
+                    </a:ext>
+                  </a:extLst>
+                </a:hlinkClick>
+              </a:rPr>
+              <a:t>A test paper with planted bugs</a:t>
+            </a:r>
+          </a:p>
+        </p:txBody>
+      </p:sp>
+      <p:pic>
+        <p:nvPicPr>
+          <p:cNvPr id="40" name="Picture 39" descr="qr_demo.png">
+            <a:hlinkClick r:id="rId3"/>
+          </p:cNvPr>
+          <p:cNvPicPr>
+            <a:picLocks noChangeAspect="1"/>
+          </p:cNvPicPr>
+          <p:nvPr/>
+        </p:nvPicPr>
+        <p:blipFill>
+          <a:blip r:embed="rId7"/>
+          <a:stretch>
+            <a:fillRect/>
+          </a:stretch>
+        </p:blipFill>
+        <p:spPr>
+          <a:xfrm>
+            <a:off x="15910559" y="3246120"/>
+            <a:ext cx="1508760" cy="1508760"/>
+          </a:xfrm>
+          <a:prstGeom prst="rect">
+            <a:avLst/>
+          </a:prstGeom>
+        </p:spPr>
+      </p:pic>
+      <p:sp>
+        <p:nvSpPr>
+          <p:cNvPr id="41" name="TextBox 40"/>
+          <p:cNvSpPr txBox="1"/>
+          <p:nvPr/>
+        </p:nvSpPr>
+        <p:spPr>
+          <a:xfrm>
+            <a:off x="9646920" y="5943600"/>
+            <a:ext cx="7772400" cy="822960"/>
+          </a:xfrm>
+          <a:prstGeom prst="rect">
+            <a:avLst/>
+          </a:prstGeom>
+          <a:noFill/>
+        </p:spPr>
+        <p:txBody>
+          <a:bodyPr wrap="square" lIns="0" rIns="0" tIns="0" bIns="0" anchor="t">
+            <a:spAutoFit/>
+          </a:bodyPr>
+          <a:lstStyle/>
+          <a:p>
+            <a:pPr algn="l">
+              <a:lnSpc>
+                <a:spcPct val="100000"/>
+              </a:lnSpc>
+              <a:spcAft>
+                <a:spcPts val="400"/>
+              </a:spcAft>
+            </a:pPr>
+            <a:r>
               <a:rPr sz="1680" b="0">
                 <a:solidFill>
                   <a:srgbClr val="FFFFFF"/>
                 </a:solidFill>
                 <a:latin typeface="Agrandir"/>
               </a:rPr>
-              <a:t>In the app: press Tour for a 90-second walkthrough, Ctrl K to search, Audit your own to upload a PDF.</a:t>
-            </a:r>
-          </a:p>
-        </p:txBody>
-      </p:sp>
-      <p:sp>
-        <p:nvSpPr>
-          <p:cNvPr id="40" name="Rounded Rectangle 39"/>
+              <a:t>In the app: press </a:t>
+            </a:r>
+            <a:r>
+              <a:rPr sz="1680" b="0" u="sng">
+                <a:solidFill>
+                  <a:srgbClr val="FFCD82"/>
+                </a:solidFill>
+                <a:latin typeface="Agrandir Bold"/>
+                <a:hlinkClick r:id="rId8">
+                  <a:extLst>
+                    <a:ext uri="{A12FA001-AC4F-418D-AE19-62706E023703}">
+                      <ahyp:hlinkClr xmlns:ahyp="http://schemas.microsoft.com/office/drawing/2018/hyperlinkcolor" val="tx"/>
+                    </a:ext>
+                  </a:extLst>
+                </a:hlinkClick>
+              </a:rPr>
+              <a:t>Tour</a:t>
+            </a:r>
+            <a:r>
+              <a:rPr sz="1680" b="0">
+                <a:solidFill>
+                  <a:srgbClr val="FFFFFF"/>
+                </a:solidFill>
+                <a:latin typeface="Agrandir"/>
+              </a:rPr>
+              <a:t> for a guided walkthrough, Ctrl K to search, Audit your own to upload a PDF.</a:t>
+            </a:r>
+          </a:p>
+        </p:txBody>
+      </p:sp>
+      <p:sp>
+        <p:nvSpPr>
+          <p:cNvPr id="42" name="Rounded Rectangle 41"/>
           <p:cNvSpPr/>
           <p:nvPr/>
         </p:nvSpPr>
@@ -19032,7 +19288,7 @@
       </p:sp>
       <p:sp>
         <p:nvSpPr>
-          <p:cNvPr id="41" name="TextBox 40"/>
+          <p:cNvPr id="43" name="TextBox 42"/>
           <p:cNvSpPr txBox="1"/>
           <p:nvPr/>
         </p:nvSpPr>
@@ -19662,7 +19918,7 @@
                 </a:solidFill>
                 <a:latin typeface="Agrandir Bold"/>
               </a:rPr>
-              <a:t>Screens from the sample reproducibility report: each one is a re-run, not an opinion</a:t>
+              <a:t>Each screen is a re-run, not an opinion. Click any one to open it live in the app.</a:t>
             </a:r>
           </a:p>
         </p:txBody>
@@ -19713,7 +19969,9 @@
       </p:sp>
       <p:pic>
         <p:nvPicPr>
-          <p:cNvPr id="18" name="Picture 17" descr="attr.png"/>
+          <p:cNvPr id="18" name="Picture 17" descr="attr.png">
+            <a:hlinkClick r:id="rId4"/>
+          </p:cNvPr>
           <p:cNvPicPr>
             <a:picLocks noChangeAspect="1"/>
           </p:cNvPicPr>
@@ -19737,7 +19995,9 @@
       </p:pic>
       <p:sp>
         <p:nvSpPr>
-          <p:cNvPr id="19" name="TextBox 18"/>
+          <p:cNvPr id="19" name="TextBox 18">
+            <a:hlinkClick r:id="rId4"/>
+          </p:cNvPr>
           <p:cNvSpPr txBox="1"/>
           <p:nvPr/>
         </p:nvSpPr>
@@ -19766,13 +20026,20 @@
               </a:spcAft>
             </a:pPr>
             <a:r>
-              <a:rPr sz="1680" b="0">
+              <a:rPr sz="1680" b="0" u="sng">
                 <a:solidFill>
                   <a:srgbClr val="003470"/>
                 </a:solidFill>
                 <a:latin typeface="Agrandir Bold"/>
-              </a:rPr>
-              <a:t>Why C1 fails: one config value explains 96% of the gap</a:t>
+                <a:hlinkClick r:id="rId4">
+                  <a:extLst>
+                    <a:ext uri="{A12FA001-AC4F-418D-AE19-62706E023703}">
+                      <ahyp:hlinkClr xmlns:ahyp="http://schemas.microsoft.com/office/drawing/2018/hyperlinkcolor" val="tx"/>
+                    </a:ext>
+                  </a:extLst>
+                </a:hlinkClick>
+              </a:rPr>
+              <a:t>Why C1 fails: one config value explains 96% of the gap →</a:t>
             </a:r>
           </a:p>
         </p:txBody>
@@ -19823,14 +20090,16 @@
       </p:sp>
       <p:pic>
         <p:nvPicPr>
-          <p:cNvPr id="21" name="Picture 20" descr="leak_crop42x100.png"/>
+          <p:cNvPr id="21" name="Picture 20" descr="leak_crop42x100.png">
+            <a:hlinkClick r:id="rId6"/>
+          </p:cNvPr>
           <p:cNvPicPr>
             <a:picLocks noChangeAspect="1"/>
           </p:cNvPicPr>
           <p:nvPr/>
         </p:nvPicPr>
         <p:blipFill>
-          <a:blip r:embed="rId4"/>
+          <a:blip r:embed="rId5"/>
           <a:stretch>
             <a:fillRect/>
           </a:stretch>
@@ -19847,7 +20116,9 @@
       </p:pic>
       <p:sp>
         <p:nvSpPr>
-          <p:cNvPr id="22" name="TextBox 21"/>
+          <p:cNvPr id="22" name="TextBox 21">
+            <a:hlinkClick r:id="rId6"/>
+          </p:cNvPr>
           <p:cNvSpPr txBox="1"/>
           <p:nvPr/>
         </p:nvSpPr>
@@ -19876,13 +20147,20 @@
               </a:spcAft>
             </a:pPr>
             <a:r>
-              <a:rPr sz="1680" b="0">
+              <a:rPr sz="1680" b="0" u="sng">
                 <a:solidFill>
                   <a:srgbClr val="003470"/>
                 </a:solidFill>
                 <a:latin typeface="Agrandir Bold"/>
-              </a:rPr>
-              <a:t>Why C5 cannot be trusted: the leak, the patch, the drop</a:t>
+                <a:hlinkClick r:id="rId6">
+                  <a:extLst>
+                    <a:ext uri="{A12FA001-AC4F-418D-AE19-62706E023703}">
+                      <ahyp:hlinkClr xmlns:ahyp="http://schemas.microsoft.com/office/drawing/2018/hyperlinkcolor" val="tx"/>
+                    </a:ext>
+                  </a:extLst>
+                </a:hlinkClick>
+              </a:rPr>
+              <a:t>Why C5 cannot be trusted: the leak, the patch, the drop →</a:t>
             </a:r>
           </a:p>
         </p:txBody>
@@ -19933,14 +20211,16 @@
       </p:sp>
       <p:pic>
         <p:nvPicPr>
-          <p:cNvPr id="24" name="Picture 23" descr="frag.png"/>
+          <p:cNvPr id="24" name="Picture 23" descr="frag.png">
+            <a:hlinkClick r:id="rId8"/>
+          </p:cNvPr>
           <p:cNvPicPr>
             <a:picLocks noChangeAspect="1"/>
           </p:cNvPicPr>
           <p:nvPr/>
         </p:nvPicPr>
         <p:blipFill>
-          <a:blip r:embed="rId5"/>
+          <a:blip r:embed="rId7"/>
           <a:stretch>
             <a:fillRect/>
           </a:stretch>
@@ -19957,7 +20237,9 @@
       </p:pic>
       <p:sp>
         <p:nvSpPr>
-          <p:cNvPr id="25" name="TextBox 24"/>
+          <p:cNvPr id="25" name="TextBox 24">
+            <a:hlinkClick r:id="rId8"/>
+          </p:cNvPr>
           <p:cNvSpPr txBox="1"/>
           <p:nvPr/>
         </p:nvSpPr>
@@ -19986,13 +20268,20 @@
               </a:spcAft>
             </a:pPr>
             <a:r>
-              <a:rPr sz="1680" b="0">
+              <a:rPr sz="1680" b="0" u="sng">
                 <a:solidFill>
                   <a:srgbClr val="003470"/>
                 </a:solidFill>
                 <a:latin typeface="Agrandir Bold"/>
-              </a:rPr>
-              <a:t>Why C7 is fragile: 15 of 30 conditions</a:t>
+                <a:hlinkClick r:id="rId8">
+                  <a:extLst>
+                    <a:ext uri="{A12FA001-AC4F-418D-AE19-62706E023703}">
+                      <ahyp:hlinkClr xmlns:ahyp="http://schemas.microsoft.com/office/drawing/2018/hyperlinkcolor" val="tx"/>
+                    </a:ext>
+                  </a:extLst>
+                </a:hlinkClick>
+              </a:rPr>
+              <a:t>Why C7 is fragile: 15 of 30 conditions →</a:t>
             </a:r>
           </a:p>
         </p:txBody>
@@ -20043,14 +20332,16 @@
       </p:sp>
       <p:pic>
         <p:nvPicPr>
-          <p:cNvPr id="27" name="Picture 26" descr="real_crop100x66.png"/>
+          <p:cNvPr id="27" name="Picture 26" descr="real_crop100x66.png">
+            <a:hlinkClick r:id="rId10"/>
+          </p:cNvPr>
           <p:cNvPicPr>
             <a:picLocks noChangeAspect="1"/>
           </p:cNvPicPr>
           <p:nvPr/>
         </p:nvPicPr>
         <p:blipFill>
-          <a:blip r:embed="rId6"/>
+          <a:blip r:embed="rId9"/>
           <a:stretch>
             <a:fillRect/>
           </a:stretch>
@@ -20191,7 +20482,9 @@
       </p:sp>
       <p:sp>
         <p:nvSpPr>
-          <p:cNvPr id="30" name="TextBox 29"/>
+          <p:cNvPr id="30" name="TextBox 29">
+            <a:hlinkClick r:id="rId10"/>
+          </p:cNvPr>
           <p:cNvSpPr txBox="1"/>
           <p:nvPr/>
         </p:nvSpPr>
@@ -20220,13 +20513,20 @@
               </a:spcAft>
             </a:pPr>
             <a:r>
-              <a:rPr sz="1680" b="0">
+              <a:rPr sz="1680" b="0" u="sng">
                 <a:solidFill>
                   <a:srgbClr val="003470"/>
                 </a:solidFill>
                 <a:latin typeface="Agrandir Bold"/>
-              </a:rPr>
-              <a:t>A real paper: one claim exact, one optimistic, and the paper's own reason</a:t>
+                <a:hlinkClick r:id="rId10">
+                  <a:extLst>
+                    <a:ext uri="{A12FA001-AC4F-418D-AE19-62706E023703}">
+                      <ahyp:hlinkClr xmlns:ahyp="http://schemas.microsoft.com/office/drawing/2018/hyperlinkcolor" val="tx"/>
+                    </a:ext>
+                  </a:extLst>
+                </a:hlinkClick>
+              </a:rPr>
+              <a:t>A real paper: one claim exact, one optimistic, and its reason →</a:t>
             </a:r>
           </a:p>
         </p:txBody>

</xml_diff>

<commit_message>
Deck: test count computed from the suite (9, not 11); tighter slide 6 lines
Co-Authored-By: Claude Opus 5.5 <noreply@anthropic.com>
</commit_message>
<xml_diff>
--- a/EL-01_TeamPreflight.pptx
+++ b/EL-01_TeamPreflight.pptx
@@ -16759,7 +16759,7 @@
                 </a:solidFill>
                 <a:latin typeface="Agrandir"/>
               </a:rPr>
-              <a:t>11 automated tests: planted, clean, live edits, real paper, server API</a:t>
+              <a:t>9 automated tests pass: planted, clean, edits, real paper, server</a:t>
             </a:r>
           </a:p>
           <a:p>
@@ -16871,7 +16871,7 @@
                 </a:solidFill>
                 <a:latin typeface="Agrandir"/>
               </a:rPr>
-              <a:t>Real 1993 paper: one claim exact, one flagged with the paper's own reason</a:t>
+              <a:t>Real 1993 paper: one claim exact, one flagged, with its reason</a:t>
             </a:r>
           </a:p>
         </p:txBody>

</xml_diff>